<commit_message>
docs: update presentation to match the shipped app
</commit_message>
<xml_diff>
--- a/docs/VitaTwin_Presentation.pptx
+++ b/docs/VitaTwin_Presentation.pptx
@@ -1517,6 +1517,10 @@
           </a:solidFill>
           <a:ln/>
         </p:spPr>
+        <p:txBody>
+          <a:bodyPr/>
+          <a:p/>
+        </p:txBody>
       </p:sp>
       <p:sp>
         <p:nvSpPr>
@@ -1654,6 +1658,10 @@
           </a:solidFill>
           <a:ln/>
         </p:spPr>
+        <p:txBody>
+          <a:bodyPr/>
+          <a:p/>
+        </p:txBody>
       </p:sp>
       <p:sp>
         <p:nvSpPr>
@@ -1744,7 +1752,7 @@
                 <a:ea typeface="Arial" pitchFamily="34" charset="-122"/>
                 <a:cs typeface="Arial" pitchFamily="34" charset="-120"/>
               </a:rPr>
-              <a:t>Team: [YOUR TEAM NAME]  ·  [College / Incubator]</a:t>
+              <a:t>CH. Pavan Sai  ·  CMR Technical Campus, Hyderabad</a:t>
             </a:r>
             <a:endParaRPr lang="en-US" sz="1300" dirty="0"/>
           </a:p>
@@ -1801,6 +1809,10 @@
           </a:solidFill>
           <a:ln/>
         </p:spPr>
+        <p:txBody>
+          <a:bodyPr/>
+          <a:p/>
+        </p:txBody>
       </p:sp>
       <p:sp>
         <p:nvSpPr>
@@ -1984,6 +1996,10 @@
             <a:prstDash val="solid"/>
           </a:ln>
         </p:spPr>
+        <p:txBody>
+          <a:bodyPr/>
+          <a:p/>
+        </p:txBody>
       </p:sp>
       <p:sp>
         <p:nvSpPr>
@@ -2089,6 +2105,10 @@
             <a:prstDash val="solid"/>
           </a:ln>
         </p:spPr>
+        <p:txBody>
+          <a:bodyPr/>
+          <a:p/>
+        </p:txBody>
       </p:sp>
       <p:sp>
         <p:nvSpPr>
@@ -2194,6 +2214,10 @@
             <a:prstDash val="solid"/>
           </a:ln>
         </p:spPr>
+        <p:txBody>
+          <a:bodyPr/>
+          <a:p/>
+        </p:txBody>
       </p:sp>
       <p:sp>
         <p:nvSpPr>
@@ -2299,6 +2323,10 @@
             <a:prstDash val="solid"/>
           </a:ln>
         </p:spPr>
+        <p:txBody>
+          <a:bodyPr/>
+          <a:p/>
+        </p:txBody>
       </p:sp>
       <p:sp>
         <p:nvSpPr>
@@ -2429,6 +2457,10 @@
           </a:solidFill>
           <a:ln/>
         </p:spPr>
+        <p:txBody>
+          <a:bodyPr/>
+          <a:p/>
+        </p:txBody>
       </p:sp>
       <p:sp>
         <p:nvSpPr>
@@ -2605,6 +2637,10 @@
           </a:solidFill>
           <a:ln/>
         </p:spPr>
+        <p:txBody>
+          <a:bodyPr/>
+          <a:p/>
+        </p:txBody>
       </p:sp>
       <p:sp>
         <p:nvSpPr>
@@ -2742,6 +2778,10 @@
           </a:solidFill>
           <a:ln/>
         </p:spPr>
+        <p:txBody>
+          <a:bodyPr/>
+          <a:p/>
+        </p:txBody>
       </p:sp>
       <p:sp>
         <p:nvSpPr>
@@ -2879,6 +2919,10 @@
           </a:solidFill>
           <a:ln/>
         </p:spPr>
+        <p:txBody>
+          <a:bodyPr/>
+          <a:p/>
+        </p:txBody>
       </p:sp>
       <p:sp>
         <p:nvSpPr>
@@ -3016,6 +3060,10 @@
           </a:solidFill>
           <a:ln/>
         </p:spPr>
+        <p:txBody>
+          <a:bodyPr/>
+          <a:p/>
+        </p:txBody>
       </p:sp>
       <p:sp>
         <p:nvSpPr>
@@ -3185,6 +3233,10 @@
           </a:solidFill>
           <a:ln/>
         </p:spPr>
+        <p:txBody>
+          <a:bodyPr/>
+          <a:p/>
+        </p:txBody>
       </p:sp>
       <p:sp>
         <p:nvSpPr>
@@ -3368,6 +3420,10 @@
             <a:prstDash val="solid"/>
           </a:ln>
         </p:spPr>
+        <p:txBody>
+          <a:bodyPr/>
+          <a:p/>
+        </p:txBody>
       </p:sp>
       <p:sp>
         <p:nvSpPr>
@@ -3388,6 +3444,10 @@
           </a:solidFill>
           <a:ln/>
         </p:spPr>
+        <p:txBody>
+          <a:bodyPr/>
+          <a:p/>
+        </p:txBody>
       </p:sp>
       <p:sp>
         <p:nvSpPr>
@@ -3493,6 +3553,10 @@
             <a:prstDash val="solid"/>
           </a:ln>
         </p:spPr>
+        <p:txBody>
+          <a:bodyPr/>
+          <a:p/>
+        </p:txBody>
       </p:sp>
       <p:sp>
         <p:nvSpPr>
@@ -3513,6 +3577,10 @@
           </a:solidFill>
           <a:ln/>
         </p:spPr>
+        <p:txBody>
+          <a:bodyPr/>
+          <a:p/>
+        </p:txBody>
       </p:sp>
       <p:sp>
         <p:nvSpPr>
@@ -3618,6 +3686,10 @@
             <a:prstDash val="solid"/>
           </a:ln>
         </p:spPr>
+        <p:txBody>
+          <a:bodyPr/>
+          <a:p/>
+        </p:txBody>
       </p:sp>
       <p:sp>
         <p:nvSpPr>
@@ -3638,6 +3710,10 @@
           </a:solidFill>
           <a:ln/>
         </p:spPr>
+        <p:txBody>
+          <a:bodyPr/>
+          <a:p/>
+        </p:txBody>
       </p:sp>
       <p:sp>
         <p:nvSpPr>
@@ -3711,7 +3787,7 @@
                 <a:ea typeface="Arial" pitchFamily="34" charset="-122"/>
                 <a:cs typeface="Arial" pitchFamily="34" charset="-120"/>
               </a:rPr>
-              <a:t>52-year-old Indian adult with hypertension, T2DM and hyperlipidaemia — aligned to national burden.</a:t>
+              <a:t>Six synthetic Indian personas. Lead twin: Rajesh, 54, Hyderabad — hypertension, T2DM and raised LDL.</a:t>
             </a:r>
             <a:endParaRPr lang="en-US" sz="1400" dirty="0"/>
           </a:p>
@@ -3768,6 +3844,10 @@
           </a:solidFill>
           <a:ln/>
         </p:spPr>
+        <p:txBody>
+          <a:bodyPr/>
+          <a:p/>
+        </p:txBody>
       </p:sp>
       <p:sp>
         <p:nvSpPr>
@@ -3951,6 +4031,10 @@
             <a:prstDash val="solid"/>
           </a:ln>
         </p:spPr>
+        <p:txBody>
+          <a:bodyPr/>
+          <a:p/>
+        </p:txBody>
       </p:sp>
       <p:sp>
         <p:nvSpPr>
@@ -4251,6 +4335,10 @@
             <a:prstDash val="solid"/>
           </a:ln>
         </p:spPr>
+        <p:txBody>
+          <a:bodyPr/>
+          <a:p/>
+        </p:txBody>
       </p:sp>
       <p:sp>
         <p:nvSpPr>
@@ -4324,7 +4412,7 @@
                 <a:ea typeface="Arial" pitchFamily="34" charset="-122"/>
                 <a:cs typeface="Arial" pitchFamily="34" charset="-120"/>
               </a:rPr>
-              <a:t>•  10-yr CVD — factor-weighted, explainable</a:t>
+              <a:t>•  10-yr CVD — Framingham 2008, South-Asian ×1.4</a:t>
             </a:r>
             <a:endParaRPr lang="en-US" sz="1400" dirty="0"/>
           </a:p>
@@ -4363,7 +4451,7 @@
                 <a:ea typeface="Arial" pitchFamily="34" charset="-122"/>
                 <a:cs typeface="Arial" pitchFamily="34" charset="-120"/>
               </a:rPr>
-              <a:t>•  Diabetes progression — HbA1c + lifestyle</a:t>
+              <a:t>•  Diabetes — IDRS + HbA1c vs ADA targets</a:t>
             </a:r>
             <a:endParaRPr lang="en-US" sz="1400" dirty="0"/>
           </a:p>
@@ -4402,7 +4490,7 @@
                 <a:ea typeface="Arial" pitchFamily="34" charset="-122"/>
                 <a:cs typeface="Arial" pitchFamily="34" charset="-120"/>
               </a:rPr>
-              <a:t>•  Acute cardiac stress — HR/HRV + sleep</a:t>
+              <a:t>•  Acute stress — HR/HRV, sleep, air quality</a:t>
             </a:r>
             <a:endParaRPr lang="en-US" sz="1400" dirty="0"/>
           </a:p>
@@ -4480,7 +4568,7 @@
                 <a:ea typeface="Arial" pitchFamily="34" charset="-122"/>
                 <a:cs typeface="Arial" pitchFamily="34" charset="-120"/>
               </a:rPr>
-              <a:t>•  What-if re-runs same validated models</a:t>
+              <a:t>•  What-if re-runs the same models</a:t>
             </a:r>
             <a:endParaRPr lang="en-US" sz="1400" dirty="0"/>
           </a:p>
@@ -4576,6 +4664,10 @@
           </a:solidFill>
           <a:ln/>
         </p:spPr>
+        <p:txBody>
+          <a:bodyPr/>
+          <a:p/>
+        </p:txBody>
       </p:sp>
       <p:sp>
         <p:nvSpPr>
@@ -4759,6 +4851,10 @@
             <a:prstDash val="solid"/>
           </a:ln>
         </p:spPr>
+        <p:txBody>
+          <a:bodyPr/>
+          <a:p/>
+        </p:txBody>
       </p:sp>
       <p:sp>
         <p:nvSpPr>
@@ -4832,7 +4928,7 @@
                 <a:ea typeface="Arial" pitchFamily="34" charset="-122"/>
                 <a:cs typeface="Arial" pitchFamily="34" charset="-120"/>
               </a:rPr>
-              <a:t>Landing, login, dashboard, vitals, insights, clinician, timeline</a:t>
+              <a:t>Landing, login, dashboard, vitals, insights, timeline, clinician, import, validation, account</a:t>
             </a:r>
             <a:endParaRPr lang="en-US" sz="1400" dirty="0"/>
           </a:p>
@@ -4864,6 +4960,10 @@
             <a:prstDash val="solid"/>
           </a:ln>
         </p:spPr>
+        <p:txBody>
+          <a:bodyPr/>
+          <a:p/>
+        </p:txBody>
       </p:sp>
       <p:sp>
         <p:nvSpPr>
@@ -4969,6 +5069,10 @@
             <a:prstDash val="solid"/>
           </a:ln>
         </p:spPr>
+        <p:txBody>
+          <a:bodyPr/>
+          <a:p/>
+        </p:txBody>
       </p:sp>
       <p:sp>
         <p:nvSpPr>
@@ -5099,6 +5203,10 @@
           </a:solidFill>
           <a:ln/>
         </p:spPr>
+        <p:txBody>
+          <a:bodyPr/>
+          <a:p/>
+        </p:txBody>
       </p:sp>
       <p:sp>
         <p:nvSpPr>
@@ -5282,6 +5390,10 @@
             <a:prstDash val="solid"/>
           </a:ln>
         </p:spPr>
+        <p:txBody>
+          <a:bodyPr/>
+          <a:p/>
+        </p:txBody>
       </p:sp>
       <p:sp>
         <p:nvSpPr>
@@ -5355,7 +5467,7 @@
                 <a:ea typeface="Arial" pitchFamily="34" charset="-122"/>
                 <a:cs typeface="Arial" pitchFamily="34" charset="-120"/>
               </a:rPr>
-              <a:t>Landing → demo twin → dashboard → vitals → insights → clinician</a:t>
+              <a:t>Landing → demo twin → dashboard → vitals → insights → import → clinician → validation</a:t>
             </a:r>
             <a:endParaRPr lang="en-US" sz="1300" dirty="0"/>
           </a:p>
@@ -5387,6 +5499,10 @@
             <a:prstDash val="solid"/>
           </a:ln>
         </p:spPr>
+        <p:txBody>
+          <a:bodyPr/>
+          <a:p/>
+        </p:txBody>
       </p:sp>
       <p:sp>
         <p:nvSpPr>
@@ -5492,6 +5608,10 @@
             <a:prstDash val="solid"/>
           </a:ln>
         </p:spPr>
+        <p:txBody>
+          <a:bodyPr/>
+          <a:p/>
+        </p:txBody>
       </p:sp>
       <p:sp>
         <p:nvSpPr>
@@ -5597,6 +5717,10 @@
             <a:prstDash val="solid"/>
           </a:ln>
         </p:spPr>
+        <p:txBody>
+          <a:bodyPr/>
+          <a:p/>
+        </p:txBody>
       </p:sp>
       <p:sp>
         <p:nvSpPr>
@@ -5670,7 +5794,7 @@
                 <a:ea typeface="Arial" pitchFamily="34" charset="-122"/>
                 <a:cs typeface="Arial" pitchFamily="34" charset="-120"/>
               </a:rPr>
-              <a:t>RLS-ready auth, rate limit, CSP/HSTS headers, scrubbed errors</a:t>
+              <a:t>RLS auth, shared rate limits, CSP/HSTS headers, scrubbed error tracking</a:t>
             </a:r>
             <a:endParaRPr lang="en-US" sz="1300" dirty="0"/>
           </a:p>
@@ -5702,6 +5826,10 @@
             <a:prstDash val="solid"/>
           </a:ln>
         </p:spPr>
+        <p:txBody>
+          <a:bodyPr/>
+          <a:p/>
+        </p:txBody>
       </p:sp>
       <p:sp>
         <p:nvSpPr>
@@ -5775,7 +5903,7 @@
                 <a:ea typeface="Arial" pitchFamily="34" charset="-122"/>
                 <a:cs typeface="Arial" pitchFamily="34" charset="-120"/>
               </a:rPr>
-              <a:t>42 unit tests, typecheck, lint, production build</a:t>
+              <a:t>98 unit + 21 e2e tests, CI, CodeQL, secret scan</a:t>
             </a:r>
             <a:endParaRPr lang="en-US" sz="1300" dirty="0"/>
           </a:p>
@@ -5807,6 +5935,10 @@
             <a:prstDash val="solid"/>
           </a:ln>
         </p:spPr>
+        <p:txBody>
+          <a:bodyPr/>
+          <a:p/>
+        </p:txBody>
       </p:sp>
       <p:sp>
         <p:nvSpPr>
@@ -5937,6 +6069,10 @@
           </a:solidFill>
           <a:ln/>
         </p:spPr>
+        <p:txBody>
+          <a:bodyPr/>
+          <a:p/>
+        </p:txBody>
       </p:sp>
       <p:sp>
         <p:nvSpPr>
@@ -6066,7 +6202,7 @@
                 <a:ea typeface="Arial" pitchFamily="34" charset="-122"/>
                 <a:cs typeface="Arial" pitchFamily="34" charset="-120"/>
               </a:rPr>
-              <a:t>Branch: feat/jury-upgrade  ·  License: MIT</a:t>
+              <a:t>Live: vita-twin-ten.vercel.app  ·  License: MIT</a:t>
             </a:r>
             <a:endParaRPr lang="en-US" sz="1400" dirty="0"/>
           </a:p>

</xml_diff>